<commit_message>
Replace IFA with GTC across demo seed data and reset templates
</commit_message>
<xml_diff>
--- a/demo/templates/rtx-spark-exec-review.pptx
+++ b/demo/templates/rtx-spark-exec-review.pptx
@@ -6780,7 +6780,7 @@
                 <a:ea typeface="Arial"/>
                 <a:cs typeface="Arial"/>
               </a:rPr>
-              <a:t>2  ALIGN ON THE DEMOS FOR IFA</a:t>
+              <a:t>2  ALIGN ON THE DEMOS FOR GTC</a:t>
             </a:r>
             <a:endParaRPr sz="1800">
               <a:solidFill>
@@ -7882,7 +7882,7 @@
                 <a:ea typeface="Arial"/>
                 <a:cs typeface="Arial"/>
               </a:rPr>
-              <a:t>Leadership needs to close the keynote storyline and IFA demo slate.</a:t>
+              <a:t>Leadership needs to close the keynote storyline and GTC demo slate.</a:t>
             </a:r>
             <a:endParaRPr sz="1700">
               <a:solidFill>
@@ -8475,7 +8475,7 @@
                 <a:ea typeface="Arial"/>
                 <a:cs typeface="Arial"/>
               </a:rPr>
-              <a:t>IFA DECK</a:t>
+              <a:t>GTC DECK</a:t>
             </a:r>
             <a:endParaRPr sz="1700">
               <a:solidFill>
@@ -9361,7 +9361,7 @@
                 <a:ea typeface="Arial"/>
                 <a:cs typeface="Arial"/>
               </a:rPr>
-              <a:t>IFA demos — alignment needed</a:t>
+              <a:t>GTC demos — alignment needed</a:t>
             </a:r>
             <a:endParaRPr sz="2800" b="1">
               <a:solidFill>

</xml_diff>

<commit_message>
Update product specifications, reference tracker, and Second Brain demo content
</commit_message>
<xml_diff>
--- a/demo/templates/rtx-spark-exec-review.pptx
+++ b/demo/templates/rtx-spark-exec-review.pptx
@@ -7300,7 +7300,7 @@
                 <a:ea typeface="Arial"/>
                 <a:cs typeface="Arial"/>
               </a:rPr>
-              <a:t>Performance, privacy, and readiness support that promise</a:t>
+              <a:t>Product specifications, privacy, and readiness support that promise</a:t>
             </a:r>
             <a:endParaRPr sz="1700">
               <a:solidFill>
@@ -8055,7 +8055,7 @@
                 <a:ea typeface="Arial"/>
                 <a:cs typeface="Arial"/>
               </a:rPr>
-              <a:t>Inference performance — update required</a:t>
+              <a:t>Product specifications: update required</a:t>
             </a:r>
             <a:endParaRPr sz="2800" b="1">
               <a:solidFill>
@@ -8127,7 +8127,7 @@
                 <a:ea typeface="Arial"/>
                 <a:cs typeface="Arial"/>
               </a:rPr>
-              <a:t>Performance to go here - Mike Chen to provide</a:t>
+              <a:t>Product specifications to go here. See Mike Chen's approved package.</a:t>
             </a:r>
             <a:endParaRPr sz="1700">
               <a:solidFill>
@@ -8611,7 +8611,7 @@
                 <a:ea typeface="Arial"/>
                 <a:cs typeface="Arial"/>
               </a:rPr>
-              <a:t>Approve wording and disclaimer once, then propagate without drift.</a:t>
+              <a:t>Keep approved specification wording, including 'up to' and FP4, consistent.</a:t>
             </a:r>
             <a:endParaRPr sz="1700">
               <a:solidFill>
@@ -8709,7 +8709,7 @@
                 <a:ea typeface="Arial"/>
                 <a:cs typeface="Arial"/>
               </a:rPr>
-              <a:t>Do not invent, extrapolate, or preserve superseded multipliers.</a:t>
+              <a:t>Do not turn product specifications into measured workflow results.</a:t>
             </a:r>
             <a:endParaRPr sz="1700">
               <a:solidFill>

</xml_diff>